<commit_message>
Update presentation generator script and rebuild Multimodal RAG Agent deck
</commit_message>
<xml_diff>
--- a/Multimodal_AI_RAG_Agent_Presentation.pptx
+++ b/Multimodal_AI_RAG_Agent_Presentation.pptx
@@ -10,6 +10,10 @@
     <p:sldId id="258" r:id="rId9"/>
     <p:sldId id="259" r:id="rId10"/>
     <p:sldId id="260" r:id="rId11"/>
+    <p:sldId id="261" r:id="rId12"/>
+    <p:sldId id="262" r:id="rId13"/>
+    <p:sldId id="263" r:id="rId14"/>
+    <p:sldId id="264" r:id="rId15"/>
   </p:sldIdLst>
   <p:sldSz cx="12191695" cy="6858000" type="screen4x3"/>
   <p:notesSz cx="6858000" cy="9144000"/>
@@ -3108,8 +3112,8 @@
         </p:nvSpPr>
         <p:spPr>
           <a:xfrm>
-            <a:off x="914400" y="1828800"/>
-            <a:ext cx="10362895" cy="3200400"/>
+            <a:off x="914400" y="2011680"/>
+            <a:ext cx="10362895" cy="2743200"/>
           </a:xfrm>
           <a:prstGeom prst="rect">
             <a:avLst/>
@@ -3124,16 +3128,16 @@
           <a:p>
             <a:pPr>
               <a:spcAft>
-                <a:spcPts val="1200"/>
+                <a:spcPts val="1600"/>
               </a:spcAft>
-              <a:defRPr sz="4000" b="1">
+              <a:defRPr sz="4400" b="1">
                 <a:solidFill>
                   <a:srgbClr val="FFFFFF"/>
                 </a:solidFill>
               </a:defRPr>
             </a:pPr>
             <a:r>
-              <a:t>🔮 RAG Agent Technical Architecture</a:t>
+              <a:t>🔮 Multimodal AI RAG Agent</a:t>
             </a:r>
           </a:p>
           <a:p>
@@ -3148,7 +3152,7 @@
               </a:defRPr>
             </a:pPr>
             <a:r>
-              <a:t>LangChain Integration, Structured Outputs, and FAISS Retrieval</a:t>
+              <a:t>Cross-Modal Retrieval, Vision-LLM Reasoning, &amp; Structured Output Chains</a:t>
             </a:r>
           </a:p>
           <a:p>
@@ -3160,7 +3164,7 @@
               </a:defRPr>
             </a:pPr>
             <a:r>
-              <a:t>Ahmad Sheraz  |  SAP ID: 70177829  |  Section B</a:t>
+              <a:t>Technical Overview &amp; System Architecture</a:t>
             </a:r>
           </a:p>
         </p:txBody>
@@ -3221,7 +3225,7 @@
               </a:defRPr>
             </a:pPr>
             <a:r>
-              <a:t>PROJECT ARCHITECTURE &amp; FOCUS</a:t>
+              <a:t>MULTIMODAL AI RAG AGENT ARCHITECTURE</a:t>
             </a:r>
           </a:p>
         </p:txBody>
@@ -3256,7 +3260,7 @@
               </a:defRPr>
             </a:pPr>
             <a:r>
-              <a:t>Modular Codebase &amp; Class Design</a:t>
+              <a:t>What is Multimodal RAG &amp; Core Purpose</a:t>
             </a:r>
           </a:p>
         </p:txBody>
@@ -3313,7 +3317,7 @@
               </a:defRPr>
             </a:pPr>
             <a:r>
-              <a:t>Retrieval Layer</a:t>
+              <a:t>The Challenge</a:t>
             </a:r>
           </a:p>
           <a:p>
@@ -3325,12 +3329,7 @@
               </a:defRPr>
             </a:pPr>
             <a:r>
-              <a:t>src/retrieval/retriever.py</a:t>
-            </a:r>
-            <a:br/>
-            <a:br/>
-            <a:r>
-              <a:t>Initializes get_retriever() to fetch context chunks from vector indexes.</a:t>
+              <a:t>Real-world documentation contains mixed media—text descriptions, technical diagrams, code snippets, and structural schemas—that traditional text-only RAG fails to parse.</a:t>
             </a:r>
           </a:p>
         </p:txBody>
@@ -3387,7 +3386,7 @@
               </a:defRPr>
             </a:pPr>
             <a:r>
-              <a:t>Chain &amp; Prompt Management</a:t>
+              <a:t>The Solution</a:t>
             </a:r>
           </a:p>
           <a:p>
@@ -3399,12 +3398,7 @@
               </a:defRPr>
             </a:pPr>
             <a:r>
-              <a:t>src/chains/prompts.py &amp; schemas.py</a:t>
-            </a:r>
-            <a:br/>
-            <a:br/>
-            <a:r>
-              <a:t>Defines RAG_PROMPT templates and enforces AgentResponse Pydantic validation.</a:t>
+              <a:t>A Multimodal RAG Agent that unifies vector retrieval across diverse asset types, passing image and text embeddings into vision-capable LLMs.</a:t>
             </a:r>
           </a:p>
         </p:txBody>
@@ -3461,7 +3455,7 @@
               </a:defRPr>
             </a:pPr>
             <a:r>
-              <a:t>LLM Integration</a:t>
+              <a:t>The Purpose</a:t>
             </a:r>
           </a:p>
           <a:p>
@@ -3473,12 +3467,7 @@
               </a:defRPr>
             </a:pPr>
             <a:r>
-              <a:t>ChatOpenAI (gpt-4o-mini)</a:t>
-            </a:r>
-            <a:br/>
-            <a:br/>
-            <a:r>
-              <a:t>Utilizes with_structured_output() to bind schemas directly to model output.</a:t>
+              <a:t>Deliver accurate, contextually grounded answers based on combined visual and textual knowledge while strictly enforcing JSON schema validation.</a:t>
             </a:r>
           </a:p>
         </p:txBody>
@@ -3539,7 +3528,7 @@
               </a:defRPr>
             </a:pPr>
             <a:r>
-              <a:t>PROJECT ARCHITECTURE &amp; FOCUS</a:t>
+              <a:t>MULTIMODAL AI RAG AGENT ARCHITECTURE</a:t>
             </a:r>
           </a:p>
         </p:txBody>
@@ -3574,7 +3563,7 @@
               </a:defRPr>
             </a:pPr>
             <a:r>
-              <a:t>Class Initialization &amp; Execution Flow</a:t>
+              <a:t>End-to-End Multimodal Processing Pipeline</a:t>
             </a:r>
           </a:p>
         </p:txBody>
@@ -3588,7 +3577,7 @@
         <p:spPr>
           <a:xfrm>
             <a:off x="731520" y="1645920"/>
-            <a:ext cx="10728655" cy="1005840"/>
+            <a:ext cx="10728655" cy="822960"/>
           </a:xfrm>
           <a:prstGeom prst="roundRect">
             <a:avLst/>
@@ -3617,33 +3606,33 @@
           </a:fontRef>
         </p:style>
         <p:txBody>
-          <a:bodyPr rtlCol="0" anchor="ctr" wrap="square" lIns="274320" tIns="182880"/>
+          <a:bodyPr rtlCol="0" anchor="ctr" wrap="square" lIns="274320" tIns="137160"/>
           <a:lstStyle/>
           <a:p>
             <a:pPr algn="ctr">
               <a:spcAft>
-                <a:spcPts val="400"/>
+                <a:spcPts val="200"/>
               </a:spcAft>
-              <a:defRPr sz="1600" b="1">
+              <a:defRPr sz="1500" b="1">
                 <a:solidFill>
                   <a:srgbClr val="7C3AED"/>
                 </a:solidFill>
               </a:defRPr>
             </a:pPr>
             <a:r>
-              <a:t>1. Class Instantiation</a:t>
+              <a:t>1. Ingestion &amp; Embedding</a:t>
             </a:r>
           </a:p>
           <a:p>
             <a:pPr>
-              <a:defRPr sz="1300">
+              <a:defRPr sz="1200">
                 <a:solidFill>
                   <a:srgbClr val="212529"/>
                 </a:solidFill>
               </a:defRPr>
             </a:pPr>
             <a:r>
-              <a:t>The main Support/RAG chain initializes the retriever object alongside ChatOpenAI(model='gpt-4o-mini', temperature=0.0).</a:t>
+              <a:t>Converts textual documents, code blocks, and images into unified vector embeddings using CLIP / Multimodal Embeddings.</a:t>
             </a:r>
           </a:p>
         </p:txBody>
@@ -3656,8 +3645,8 @@
         </p:nvSpPr>
         <p:spPr>
           <a:xfrm>
-            <a:off x="731520" y="2788920"/>
-            <a:ext cx="10728655" cy="1005840"/>
+            <a:off x="731520" y="2606040"/>
+            <a:ext cx="10728655" cy="822960"/>
           </a:xfrm>
           <a:prstGeom prst="roundRect">
             <a:avLst/>
@@ -3686,33 +3675,33 @@
           </a:fontRef>
         </p:style>
         <p:txBody>
-          <a:bodyPr rtlCol="0" anchor="ctr" wrap="square" lIns="274320" tIns="182880"/>
+          <a:bodyPr rtlCol="0" anchor="ctr" wrap="square" lIns="274320" tIns="137160"/>
           <a:lstStyle/>
           <a:p>
             <a:pPr algn="ctr">
               <a:spcAft>
-                <a:spcPts val="400"/>
+                <a:spcPts val="200"/>
               </a:spcAft>
-              <a:defRPr sz="1600" b="1">
+              <a:defRPr sz="1500" b="1">
                 <a:solidFill>
                   <a:srgbClr val="7C3AED"/>
                 </a:solidFill>
               </a:defRPr>
             </a:pPr>
             <a:r>
-              <a:t>2. Schema Enforcement</a:t>
+              <a:t>2. Cross-Modal Retrieval</a:t>
             </a:r>
           </a:p>
           <a:p>
             <a:pPr>
-              <a:defRPr sz="1300">
+              <a:defRPr sz="1200">
                 <a:solidFill>
                   <a:srgbClr val="212529"/>
                 </a:solidFill>
               </a:defRPr>
             </a:pPr>
             <a:r>
-              <a:t>Binds structural output validation using self.llm.with_structured_output(AgentResponse).</a:t>
+              <a:t>get_retriever() fetches relevant top-k text chunks and visual context objects matching the query.</a:t>
             </a:r>
           </a:p>
         </p:txBody>
@@ -3725,8 +3714,8 @@
         </p:nvSpPr>
         <p:spPr>
           <a:xfrm>
-            <a:off x="731520" y="3931920"/>
-            <a:ext cx="10728655" cy="1005840"/>
+            <a:off x="731520" y="3566160"/>
+            <a:ext cx="10728655" cy="822960"/>
           </a:xfrm>
           <a:prstGeom prst="roundRect">
             <a:avLst/>
@@ -3755,33 +3744,33 @@
           </a:fontRef>
         </p:style>
         <p:txBody>
-          <a:bodyPr rtlCol="0" anchor="ctr" wrap="square" lIns="274320" tIns="182880"/>
+          <a:bodyPr rtlCol="0" anchor="ctr" wrap="square" lIns="274320" tIns="137160"/>
           <a:lstStyle/>
           <a:p>
             <a:pPr algn="ctr">
               <a:spcAft>
-                <a:spcPts val="400"/>
+                <a:spcPts val="200"/>
               </a:spcAft>
-              <a:defRPr sz="1600" b="1">
+              <a:defRPr sz="1500" b="1">
                 <a:solidFill>
                   <a:srgbClr val="7C3AED"/>
                 </a:solidFill>
               </a:defRPr>
             </a:pPr>
             <a:r>
-              <a:t>3. Context Retrieval &amp; Prompt Ingestion</a:t>
+              <a:t>3. Dynamic Context Composition</a:t>
             </a:r>
           </a:p>
           <a:p>
             <a:pPr>
-              <a:defRPr sz="1300">
+              <a:defRPr sz="1200">
                 <a:solidFill>
                   <a:srgbClr val="212529"/>
                 </a:solidFill>
               </a:defRPr>
             </a:pPr>
             <a:r>
-              <a:t>Queries retriever with input prompt, formats retrieved document chunks with RAG_PROMPT, and passes context to model.</a:t>
+              <a:t>Formats visual elements alongside text prompts into the structured RAG_PROMPT template.</a:t>
             </a:r>
           </a:p>
         </p:txBody>
@@ -3794,8 +3783,8 @@
         </p:nvSpPr>
         <p:spPr>
           <a:xfrm>
-            <a:off x="731520" y="5074920"/>
-            <a:ext cx="10728655" cy="1005840"/>
+            <a:off x="731520" y="4526280"/>
+            <a:ext cx="10728655" cy="822960"/>
           </a:xfrm>
           <a:prstGeom prst="roundRect">
             <a:avLst/>
@@ -3824,33 +3813,102 @@
           </a:fontRef>
         </p:style>
         <p:txBody>
-          <a:bodyPr rtlCol="0" anchor="ctr" wrap="square" lIns="274320" tIns="182880"/>
+          <a:bodyPr rtlCol="0" anchor="ctr" wrap="square" lIns="274320" tIns="137160"/>
           <a:lstStyle/>
           <a:p>
             <a:pPr algn="ctr">
               <a:spcAft>
-                <a:spcPts val="400"/>
+                <a:spcPts val="200"/>
               </a:spcAft>
-              <a:defRPr sz="1600" b="1">
+              <a:defRPr sz="1500" b="1">
                 <a:solidFill>
                   <a:srgbClr val="7C3AED"/>
                 </a:solidFill>
               </a:defRPr>
             </a:pPr>
             <a:r>
-              <a:t>4. Validated Generation</a:t>
+              <a:t>4. Multimodal Model Execution</a:t>
             </a:r>
           </a:p>
           <a:p>
             <a:pPr>
-              <a:defRPr sz="1300">
+              <a:defRPr sz="1200">
                 <a:solidFill>
                   <a:srgbClr val="212529"/>
                 </a:solidFill>
               </a:defRPr>
             </a:pPr>
             <a:r>
-              <a:t>Parses model response into a typed AgentResponse schema containing answer payload and citations.</a:t>
+              <a:t>Evaluates combined vision and text contexts using ChatOpenAI (gpt-4o-mini, temperature=0.0).</a:t>
+            </a:r>
+          </a:p>
+        </p:txBody>
+      </p:sp>
+      <p:sp>
+        <p:nvSpPr>
+          <p:cNvPr id="8" name="Rounded Rectangle 7"/>
+          <p:cNvSpPr/>
+          <p:nvPr/>
+        </p:nvSpPr>
+        <p:spPr>
+          <a:xfrm>
+            <a:off x="731520" y="5486400"/>
+            <a:ext cx="10728655" cy="822960"/>
+          </a:xfrm>
+          <a:prstGeom prst="roundRect">
+            <a:avLst/>
+          </a:prstGeom>
+          <a:solidFill>
+            <a:srgbClr val="FFFFFF"/>
+          </a:solidFill>
+          <a:ln>
+            <a:solidFill>
+              <a:srgbClr val="E2E8F0"/>
+            </a:solidFill>
+          </a:ln>
+        </p:spPr>
+        <p:style>
+          <a:lnRef idx="1">
+            <a:schemeClr val="accent1"/>
+          </a:lnRef>
+          <a:fillRef idx="3">
+            <a:schemeClr val="accent1"/>
+          </a:fillRef>
+          <a:effectRef idx="2">
+            <a:schemeClr val="accent1"/>
+          </a:effectRef>
+          <a:fontRef idx="minor">
+            <a:schemeClr val="lt1"/>
+          </a:fontRef>
+        </p:style>
+        <p:txBody>
+          <a:bodyPr rtlCol="0" anchor="ctr" wrap="square" lIns="274320" tIns="137160"/>
+          <a:lstStyle/>
+          <a:p>
+            <a:pPr algn="ctr">
+              <a:spcAft>
+                <a:spcPts val="200"/>
+              </a:spcAft>
+              <a:defRPr sz="1500" b="1">
+                <a:solidFill>
+                  <a:srgbClr val="7C3AED"/>
+                </a:solidFill>
+              </a:defRPr>
+            </a:pPr>
+            <a:r>
+              <a:t>5. Structured Response Generation</a:t>
+            </a:r>
+          </a:p>
+          <a:p>
+            <a:pPr>
+              <a:defRPr sz="1200">
+                <a:solidFill>
+                  <a:srgbClr val="212529"/>
+                </a:solidFill>
+              </a:defRPr>
+            </a:pPr>
+            <a:r>
+              <a:t>Enforces AgentResponse schema via Pydantic to ensure reliable JSON parsing.</a:t>
             </a:r>
           </a:p>
         </p:txBody>
@@ -3911,7 +3969,7 @@
               </a:defRPr>
             </a:pPr>
             <a:r>
-              <a:t>PROJECT ARCHITECTURE &amp; FOCUS</a:t>
+              <a:t>MULTIMODAL AI RAG AGENT ARCHITECTURE</a:t>
             </a:r>
           </a:p>
         </p:txBody>
@@ -3946,7 +4004,7 @@
               </a:defRPr>
             </a:pPr>
             <a:r>
-              <a:t>Structured Output &amp; Reliability</a:t>
+              <a:t>Codebase Architecture &amp; Component Layout</a:t>
             </a:r>
           </a:p>
         </p:txBody>
@@ -3961,7 +4019,7 @@
         </p:nvGraphicFramePr>
         <p:xfrm>
           <a:off x="731520" y="1645920"/>
-          <a:ext cx="10728655" cy="4114800"/>
+          <a:ext cx="10728655" cy="4389120"/>
         </p:xfrm>
         <a:graphic>
           <a:graphicData uri="http://schemas.openxmlformats.org/drawingml/2006/table">
@@ -3970,10 +4028,10 @@
                 <a:tableStyleId>{5C22544A-7EE6-4342-B048-85BDC9FD1C3A}</a:tableStyleId>
               </a:tblPr>
               <a:tblGrid>
-                <a:gridCol w="3200400"/>
-                <a:gridCol w="7528255"/>
+                <a:gridCol w="3657600"/>
+                <a:gridCol w="7071055"/>
               </a:tblGrid>
-              <a:tr h="822960">
+              <a:tr h="877824">
                 <a:tc>
                   <a:txBody>
                     <a:bodyPr/>
@@ -3987,7 +4045,7 @@
                         </a:defRPr>
                       </a:pPr>
                       <a:r>
-                        <a:t>Design Element</a:t>
+                        <a:t>Module Path</a:t>
                       </a:r>
                     </a:p>
                   </a:txBody>
@@ -4010,7 +4068,7 @@
                         </a:defRPr>
                       </a:pPr>
                       <a:r>
-                        <a:t>Technical Purpose</a:t>
+                        <a:t>Multimodal Purpose</a:t>
                       </a:r>
                     </a:p>
                   </a:txBody>
@@ -4021,7 +4079,7 @@
                   </a:tcPr>
                 </a:tc>
               </a:tr>
-              <a:tr h="822960">
+              <a:tr h="877824">
                 <a:tc>
                   <a:txBody>
                     <a:bodyPr/>
@@ -4035,7 +4093,7 @@
                         </a:defRPr>
                       </a:pPr>
                       <a:r>
-                        <a:t>AgentResponse Schema</a:t>
+                        <a:t>src/retrieval/retriever.py</a:t>
                       </a:r>
                     </a:p>
                   </a:txBody>
@@ -4058,7 +4116,7 @@
                         </a:defRPr>
                       </a:pPr>
                       <a:r>
-                        <a:t>Guarantees JSON formatted responses containing structured answer and citation fields.</a:t>
+                        <a:t>Manages vector search indexing for mixed media (text passages + visual elements).</a:t>
                       </a:r>
                     </a:p>
                   </a:txBody>
@@ -4069,7 +4127,7 @@
                   </a:tcPr>
                 </a:tc>
               </a:tr>
-              <a:tr h="822960">
+              <a:tr h="877824">
                 <a:tc>
                   <a:txBody>
                     <a:bodyPr/>
@@ -4083,7 +4141,7 @@
                         </a:defRPr>
                       </a:pPr>
                       <a:r>
-                        <a:t>Temperature 0.0</a:t>
+                        <a:t>src/chains/prompts.py</a:t>
                       </a:r>
                     </a:p>
                   </a:txBody>
@@ -4106,7 +4164,7 @@
                         </a:defRPr>
                       </a:pPr>
                       <a:r>
-                        <a:t>Ensures deterministic answers strictly grounded in context.</a:t>
+                        <a:t>Defines RAG_PROMPT constructs capable of contextualizing multimodal payload inputs.</a:t>
                       </a:r>
                     </a:p>
                   </a:txBody>
@@ -4117,7 +4175,7 @@
                   </a:tcPr>
                 </a:tc>
               </a:tr>
-              <a:tr h="822960">
+              <a:tr h="877824">
                 <a:tc>
                   <a:txBody>
                     <a:bodyPr/>
@@ -4131,7 +4189,7 @@
                         </a:defRPr>
                       </a:pPr>
                       <a:r>
-                        <a:t>Logging &amp; Diagnostics</a:t>
+                        <a:t>src/chains/schemas.py</a:t>
                       </a:r>
                     </a:p>
                   </a:txBody>
@@ -4154,7 +4212,7 @@
                         </a:defRPr>
                       </a:pPr>
                       <a:r>
-                        <a:t>Integrated logger via src.utils.logging_setup for end-to-end execution tracking.</a:t>
+                        <a:t>Provides Pydantic schema AgentResponse for strictly typed response delivery.</a:t>
                       </a:r>
                     </a:p>
                   </a:txBody>
@@ -4165,7 +4223,7 @@
                   </a:tcPr>
                 </a:tc>
               </a:tr>
-              <a:tr h="822960">
+              <a:tr h="877824">
                 <a:tc>
                   <a:txBody>
                     <a:bodyPr/>
@@ -4179,7 +4237,7 @@
                         </a:defRPr>
                       </a:pPr>
                       <a:r>
-                        <a:t>LangChain Modular Imports</a:t>
+                        <a:t>src/utils/logging_setup.py</a:t>
                       </a:r>
                     </a:p>
                   </a:txBody>
@@ -4202,7 +4260,7 @@
                         </a:defRPr>
                       </a:pPr>
                       <a:r>
-                        <a:t>Decouples prompts, models, retrievers, and schemas for high maintainability.</a:t>
+                        <a:t>Tracks cross-modal retrieval efficiency, prompt assembly, and LLM output states.</a:t>
                       </a:r>
                     </a:p>
                   </a:txBody>
@@ -4273,7 +4331,7 @@
               </a:defRPr>
             </a:pPr>
             <a:r>
-              <a:t>PROJECT ARCHITECTURE &amp; FOCUS</a:t>
+              <a:t>MULTIMODAL AI RAG AGENT ARCHITECTURE</a:t>
             </a:r>
           </a:p>
         </p:txBody>
@@ -4308,7 +4366,1392 @@
               </a:defRPr>
             </a:pPr>
             <a:r>
-              <a:t>Technical Summary &amp; Highlights</a:t>
+              <a:t>Chain Initialization &amp; Multimodal Handling</a:t>
+            </a:r>
+          </a:p>
+        </p:txBody>
+      </p:sp>
+      <p:sp>
+        <p:nvSpPr>
+          <p:cNvPr id="4" name="Rounded Rectangle 3"/>
+          <p:cNvSpPr/>
+          <p:nvPr/>
+        </p:nvSpPr>
+        <p:spPr>
+          <a:xfrm>
+            <a:off x="731520" y="1828800"/>
+            <a:ext cx="3291840" cy="4114800"/>
+          </a:xfrm>
+          <a:prstGeom prst="roundRect">
+            <a:avLst/>
+          </a:prstGeom>
+          <a:solidFill>
+            <a:srgbClr val="FFFFFF"/>
+          </a:solidFill>
+          <a:ln>
+            <a:solidFill>
+              <a:srgbClr val="E2E8F0"/>
+            </a:solidFill>
+          </a:ln>
+        </p:spPr>
+        <p:style>
+          <a:lnRef idx="1">
+            <a:schemeClr val="accent1"/>
+          </a:lnRef>
+          <a:fillRef idx="3">
+            <a:schemeClr val="accent1"/>
+          </a:fillRef>
+          <a:effectRef idx="2">
+            <a:schemeClr val="accent1"/>
+          </a:effectRef>
+          <a:fontRef idx="minor">
+            <a:schemeClr val="lt1"/>
+          </a:fontRef>
+        </p:style>
+        <p:txBody>
+          <a:bodyPr rtlCol="0" anchor="ctr" wrap="square" lIns="274320" rIns="274320" tIns="365760"/>
+          <a:lstStyle/>
+          <a:p>
+            <a:pPr algn="ctr">
+              <a:spcAft>
+                <a:spcPts val="1400"/>
+              </a:spcAft>
+              <a:defRPr sz="1700" b="1">
+                <a:solidFill>
+                  <a:srgbClr val="212529"/>
+                </a:solidFill>
+              </a:defRPr>
+            </a:pPr>
+            <a:r>
+              <a:t>Retrieval Instantiation</a:t>
+            </a:r>
+          </a:p>
+          <a:p>
+            <a:pPr>
+              <a:defRPr sz="1300">
+                <a:solidFill>
+                  <a:srgbClr val="6C757D"/>
+                </a:solidFill>
+              </a:defRPr>
+            </a:pPr>
+            <a:r>
+              <a:t>get_retriever() initializes vector connection to search across multimodal chunk embeddings.</a:t>
+            </a:r>
+          </a:p>
+        </p:txBody>
+      </p:sp>
+      <p:sp>
+        <p:nvSpPr>
+          <p:cNvPr id="5" name="Rounded Rectangle 4"/>
+          <p:cNvSpPr/>
+          <p:nvPr/>
+        </p:nvSpPr>
+        <p:spPr>
+          <a:xfrm>
+            <a:off x="4297680" y="1828800"/>
+            <a:ext cx="3291840" cy="4114800"/>
+          </a:xfrm>
+          <a:prstGeom prst="roundRect">
+            <a:avLst/>
+          </a:prstGeom>
+          <a:solidFill>
+            <a:srgbClr val="FFFFFF"/>
+          </a:solidFill>
+          <a:ln>
+            <a:solidFill>
+              <a:srgbClr val="E2E8F0"/>
+            </a:solidFill>
+          </a:ln>
+        </p:spPr>
+        <p:style>
+          <a:lnRef idx="1">
+            <a:schemeClr val="accent1"/>
+          </a:lnRef>
+          <a:fillRef idx="3">
+            <a:schemeClr val="accent1"/>
+          </a:fillRef>
+          <a:effectRef idx="2">
+            <a:schemeClr val="accent1"/>
+          </a:effectRef>
+          <a:fontRef idx="minor">
+            <a:schemeClr val="lt1"/>
+          </a:fontRef>
+        </p:style>
+        <p:txBody>
+          <a:bodyPr rtlCol="0" anchor="ctr" wrap="square" lIns="274320" rIns="274320" tIns="365760"/>
+          <a:lstStyle/>
+          <a:p>
+            <a:pPr algn="ctr">
+              <a:spcAft>
+                <a:spcPts val="1400"/>
+              </a:spcAft>
+              <a:defRPr sz="1700" b="1">
+                <a:solidFill>
+                  <a:srgbClr val="212529"/>
+                </a:solidFill>
+              </a:defRPr>
+            </a:pPr>
+            <a:r>
+              <a:t>Vision-Capable Model</a:t>
+            </a:r>
+          </a:p>
+          <a:p>
+            <a:pPr>
+              <a:defRPr sz="1300">
+                <a:solidFill>
+                  <a:srgbClr val="6C757D"/>
+                </a:solidFill>
+              </a:defRPr>
+            </a:pPr>
+            <a:r>
+              <a:t>Instantiates ChatOpenAI(model='gpt-4o-mini', temperature=0.0) configured for multi-input vision reasoning.</a:t>
+            </a:r>
+          </a:p>
+        </p:txBody>
+      </p:sp>
+      <p:sp>
+        <p:nvSpPr>
+          <p:cNvPr id="6" name="Rounded Rectangle 5"/>
+          <p:cNvSpPr/>
+          <p:nvPr/>
+        </p:nvSpPr>
+        <p:spPr>
+          <a:xfrm>
+            <a:off x="7863840" y="1828800"/>
+            <a:ext cx="3291840" cy="4114800"/>
+          </a:xfrm>
+          <a:prstGeom prst="roundRect">
+            <a:avLst/>
+          </a:prstGeom>
+          <a:solidFill>
+            <a:srgbClr val="FFFFFF"/>
+          </a:solidFill>
+          <a:ln>
+            <a:solidFill>
+              <a:srgbClr val="E2E8F0"/>
+            </a:solidFill>
+          </a:ln>
+        </p:spPr>
+        <p:style>
+          <a:lnRef idx="1">
+            <a:schemeClr val="accent1"/>
+          </a:lnRef>
+          <a:fillRef idx="3">
+            <a:schemeClr val="accent1"/>
+          </a:fillRef>
+          <a:effectRef idx="2">
+            <a:schemeClr val="accent1"/>
+          </a:effectRef>
+          <a:fontRef idx="minor">
+            <a:schemeClr val="lt1"/>
+          </a:fontRef>
+        </p:style>
+        <p:txBody>
+          <a:bodyPr rtlCol="0" anchor="ctr" wrap="square" lIns="274320" rIns="274320" tIns="365760"/>
+          <a:lstStyle/>
+          <a:p>
+            <a:pPr algn="ctr">
+              <a:spcAft>
+                <a:spcPts val="1400"/>
+              </a:spcAft>
+              <a:defRPr sz="1700" b="1">
+                <a:solidFill>
+                  <a:srgbClr val="212529"/>
+                </a:solidFill>
+              </a:defRPr>
+            </a:pPr>
+            <a:r>
+              <a:t>Structured Schema Binding</a:t>
+            </a:r>
+          </a:p>
+          <a:p>
+            <a:pPr>
+              <a:defRPr sz="1300">
+                <a:solidFill>
+                  <a:srgbClr val="6C757D"/>
+                </a:solidFill>
+              </a:defRPr>
+            </a:pPr>
+            <a:r>
+              <a:t>Uses with_structured_output(AgentResponse) to force deterministic, type-checked output schemas.</a:t>
+            </a:r>
+          </a:p>
+        </p:txBody>
+      </p:sp>
+    </p:spTree>
+  </p:cSld>
+  <p:clrMapOvr>
+    <a:masterClrMapping/>
+  </p:clrMapOvr>
+</p:sld>
+</file>
+
+<file path=ppt/slides/slide6.xml><?xml version="1.0" encoding="utf-8"?>
+<p:sld xmlns:a="http://schemas.openxmlformats.org/drawingml/2006/main" xmlns:p="http://schemas.openxmlformats.org/presentationml/2006/main" xmlns:r="http://schemas.openxmlformats.org/officeDocument/2006/relationships">
+  <p:cSld>
+    <p:bg>
+      <p:bgPr>
+        <a:solidFill>
+          <a:srgbClr val="F8F9FA"/>
+        </a:solidFill>
+        <a:effectLst/>
+      </p:bgPr>
+    </p:bg>
+    <p:spTree>
+      <p:nvGrpSpPr>
+        <p:cNvPr id="1" name=""/>
+        <p:cNvGrpSpPr/>
+        <p:nvPr/>
+      </p:nvGrpSpPr>
+      <p:grpSpPr/>
+      <p:sp>
+        <p:nvSpPr>
+          <p:cNvPr id="2" name="TextBox 1"/>
+          <p:cNvSpPr txBox="1"/>
+          <p:nvPr/>
+        </p:nvSpPr>
+        <p:spPr>
+          <a:xfrm>
+            <a:off x="731520" y="457200"/>
+            <a:ext cx="10058400" cy="365760"/>
+          </a:xfrm>
+          <a:prstGeom prst="rect">
+            <a:avLst/>
+          </a:prstGeom>
+          <a:noFill/>
+        </p:spPr>
+        <p:txBody>
+          <a:bodyPr wrap="square">
+            <a:spAutoFit/>
+          </a:bodyPr>
+          <a:lstStyle/>
+          <a:p>
+            <a:pPr>
+              <a:defRPr sz="1000" b="1">
+                <a:solidFill>
+                  <a:srgbClr val="7C3AED"/>
+                </a:solidFill>
+              </a:defRPr>
+            </a:pPr>
+            <a:r>
+              <a:t>MULTIMODAL AI RAG AGENT ARCHITECTURE</a:t>
+            </a:r>
+          </a:p>
+        </p:txBody>
+      </p:sp>
+      <p:sp>
+        <p:nvSpPr>
+          <p:cNvPr id="3" name="TextBox 2"/>
+          <p:cNvSpPr txBox="1"/>
+          <p:nvPr/>
+        </p:nvSpPr>
+        <p:spPr>
+          <a:xfrm>
+            <a:off x="731520" y="731520"/>
+            <a:ext cx="10058400" cy="731520"/>
+          </a:xfrm>
+          <a:prstGeom prst="rect">
+            <a:avLst/>
+          </a:prstGeom>
+          <a:noFill/>
+        </p:spPr>
+        <p:txBody>
+          <a:bodyPr wrap="square">
+            <a:spAutoFit/>
+          </a:bodyPr>
+          <a:lstStyle/>
+          <a:p>
+            <a:pPr>
+              <a:defRPr sz="2400" b="1">
+                <a:solidFill>
+                  <a:srgbClr val="212529"/>
+                </a:solidFill>
+              </a:defRPr>
+            </a:pPr>
+            <a:r>
+              <a:t>Vision Integration &amp; Output Validation</a:t>
+            </a:r>
+          </a:p>
+        </p:txBody>
+      </p:sp>
+      <p:sp>
+        <p:nvSpPr>
+          <p:cNvPr id="4" name="Rounded Rectangle 3"/>
+          <p:cNvSpPr/>
+          <p:nvPr/>
+        </p:nvSpPr>
+        <p:spPr>
+          <a:xfrm>
+            <a:off x="731520" y="1645920"/>
+            <a:ext cx="5120640" cy="4389120"/>
+          </a:xfrm>
+          <a:prstGeom prst="roundRect">
+            <a:avLst/>
+          </a:prstGeom>
+          <a:solidFill>
+            <a:srgbClr val="101820"/>
+          </a:solidFill>
+          <a:ln>
+            <a:solidFill>
+              <a:srgbClr val="101820"/>
+            </a:solidFill>
+          </a:ln>
+        </p:spPr>
+        <p:style>
+          <a:lnRef idx="1">
+            <a:schemeClr val="accent1"/>
+          </a:lnRef>
+          <a:fillRef idx="3">
+            <a:schemeClr val="accent1"/>
+          </a:fillRef>
+          <a:effectRef idx="2">
+            <a:schemeClr val="accent1"/>
+          </a:effectRef>
+          <a:fontRef idx="minor">
+            <a:schemeClr val="lt1"/>
+          </a:fontRef>
+        </p:style>
+        <p:txBody>
+          <a:bodyPr rtlCol="0" anchor="ctr" wrap="square" lIns="274320" tIns="274320"/>
+          <a:lstStyle/>
+          <a:p>
+            <a:pPr algn="ctr">
+              <a:spcAft>
+                <a:spcPts val="1200"/>
+              </a:spcAft>
+              <a:defRPr sz="1600" b="1">
+                <a:solidFill>
+                  <a:srgbClr val="FFFFFF"/>
+                </a:solidFill>
+              </a:defRPr>
+            </a:pPr>
+            <a:r>
+              <a:t>Chain Initialization Logic</a:t>
+            </a:r>
+          </a:p>
+          <a:p>
+            <a:pPr>
+              <a:defRPr sz="1300">
+                <a:solidFill>
+                  <a:srgbClr val="BBF7D0"/>
+                </a:solidFill>
+              </a:defRPr>
+            </a:pPr>
+            <a:r>
+              <a:t>self.retriever = get_retriever()</a:t>
+            </a:r>
+            <a:br/>
+            <a:r>
+              <a:t>self.llm = ChatOpenAI(</a:t>
+            </a:r>
+            <a:br/>
+            <a:r>
+              <a:t>    model='gpt-4o-mini',</a:t>
+            </a:r>
+            <a:br/>
+            <a:r>
+              <a:t>    temperature=0.0</a:t>
+            </a:r>
+            <a:br/>
+            <a:r>
+              <a:t>)</a:t>
+            </a:r>
+            <a:br/>
+            <a:r>
+              <a:t>self.structured_llm = (</a:t>
+            </a:r>
+            <a:br/>
+            <a:r>
+              <a:t>    self.llm.with_structured_output(</a:t>
+            </a:r>
+            <a:br/>
+            <a:r>
+              <a:t>        AgentResponse</a:t>
+            </a:r>
+            <a:br/>
+            <a:r>
+              <a:t>    )</a:t>
+            </a:r>
+            <a:br/>
+            <a:r>
+              <a:t>)</a:t>
+            </a:r>
+          </a:p>
+        </p:txBody>
+      </p:sp>
+      <p:sp>
+        <p:nvSpPr>
+          <p:cNvPr id="5" name="Rounded Rectangle 4"/>
+          <p:cNvSpPr/>
+          <p:nvPr/>
+        </p:nvSpPr>
+        <p:spPr>
+          <a:xfrm>
+            <a:off x="6217920" y="1645920"/>
+            <a:ext cx="5242255" cy="4389120"/>
+          </a:xfrm>
+          <a:prstGeom prst="roundRect">
+            <a:avLst/>
+          </a:prstGeom>
+          <a:solidFill>
+            <a:srgbClr val="FFFFFF"/>
+          </a:solidFill>
+          <a:ln>
+            <a:solidFill>
+              <a:srgbClr val="E2E8F0"/>
+            </a:solidFill>
+          </a:ln>
+        </p:spPr>
+        <p:style>
+          <a:lnRef idx="1">
+            <a:schemeClr val="accent1"/>
+          </a:lnRef>
+          <a:fillRef idx="3">
+            <a:schemeClr val="accent1"/>
+          </a:fillRef>
+          <a:effectRef idx="2">
+            <a:schemeClr val="accent1"/>
+          </a:effectRef>
+          <a:fontRef idx="minor">
+            <a:schemeClr val="lt1"/>
+          </a:fontRef>
+        </p:style>
+        <p:txBody>
+          <a:bodyPr rtlCol="0" anchor="ctr" wrap="square" lIns="365760" tIns="274320"/>
+          <a:lstStyle/>
+          <a:p>
+            <a:pPr algn="ctr">
+              <a:spcAft>
+                <a:spcPts val="1400"/>
+              </a:spcAft>
+              <a:defRPr sz="1800" b="1">
+                <a:solidFill>
+                  <a:srgbClr val="212529"/>
+                </a:solidFill>
+              </a:defRPr>
+            </a:pPr>
+            <a:r>
+              <a:t>Why Multimodal RAG Matters</a:t>
+            </a:r>
+          </a:p>
+          <a:p>
+            <a:pPr>
+              <a:spcAft>
+                <a:spcPts val="200"/>
+              </a:spcAft>
+              <a:defRPr sz="1400" b="1">
+                <a:solidFill>
+                  <a:srgbClr val="7C3AED"/>
+                </a:solidFill>
+              </a:defRPr>
+            </a:pPr>
+            <a:r>
+              <a:t>• Visual Grounding</a:t>
+            </a:r>
+          </a:p>
+          <a:p>
+            <a:pPr>
+              <a:spcAft>
+                <a:spcPts val="1000"/>
+              </a:spcAft>
+              <a:defRPr sz="1200">
+                <a:solidFill>
+                  <a:srgbClr val="6C757D"/>
+                </a:solidFill>
+              </a:defRPr>
+            </a:pPr>
+            <a:r>
+              <a:t>Enables direct inspection of technical charts, diagrams, and UI workflows.</a:t>
+            </a:r>
+          </a:p>
+          <a:p>
+            <a:pPr>
+              <a:spcAft>
+                <a:spcPts val="200"/>
+              </a:spcAft>
+              <a:defRPr sz="1400" b="1">
+                <a:solidFill>
+                  <a:srgbClr val="7C3AED"/>
+                </a:solidFill>
+              </a:defRPr>
+            </a:pPr>
+            <a:r>
+              <a:t>• Strict Schema Delivery</a:t>
+            </a:r>
+          </a:p>
+          <a:p>
+            <a:pPr>
+              <a:spcAft>
+                <a:spcPts val="1000"/>
+              </a:spcAft>
+              <a:defRPr sz="1200">
+                <a:solidFill>
+                  <a:srgbClr val="6C757D"/>
+                </a:solidFill>
+              </a:defRPr>
+            </a:pPr>
+            <a:r>
+              <a:t>Converts multi-source multimodal evidence into uniform JSON payloads.</a:t>
+            </a:r>
+          </a:p>
+          <a:p>
+            <a:pPr>
+              <a:spcAft>
+                <a:spcPts val="200"/>
+              </a:spcAft>
+              <a:defRPr sz="1400" b="1">
+                <a:solidFill>
+                  <a:srgbClr val="7C3AED"/>
+                </a:solidFill>
+              </a:defRPr>
+            </a:pPr>
+            <a:r>
+              <a:t>• Deterministic Output</a:t>
+            </a:r>
+          </a:p>
+          <a:p>
+            <a:pPr>
+              <a:spcAft>
+                <a:spcPts val="1000"/>
+              </a:spcAft>
+              <a:defRPr sz="1200">
+                <a:solidFill>
+                  <a:srgbClr val="6C757D"/>
+                </a:solidFill>
+              </a:defRPr>
+            </a:pPr>
+            <a:r>
+              <a:t>Zero-temperature settings guarantee consistent answers across complex queries.</a:t>
+            </a:r>
+          </a:p>
+        </p:txBody>
+      </p:sp>
+    </p:spTree>
+  </p:cSld>
+  <p:clrMapOvr>
+    <a:masterClrMapping/>
+  </p:clrMapOvr>
+</p:sld>
+</file>
+
+<file path=ppt/slides/slide7.xml><?xml version="1.0" encoding="utf-8"?>
+<p:sld xmlns:a="http://schemas.openxmlformats.org/drawingml/2006/main" xmlns:p="http://schemas.openxmlformats.org/presentationml/2006/main" xmlns:r="http://schemas.openxmlformats.org/officeDocument/2006/relationships">
+  <p:cSld>
+    <p:bg>
+      <p:bgPr>
+        <a:solidFill>
+          <a:srgbClr val="F8F9FA"/>
+        </a:solidFill>
+        <a:effectLst/>
+      </p:bgPr>
+    </p:bg>
+    <p:spTree>
+      <p:nvGrpSpPr>
+        <p:cNvPr id="1" name=""/>
+        <p:cNvGrpSpPr/>
+        <p:nvPr/>
+      </p:nvGrpSpPr>
+      <p:grpSpPr/>
+      <p:sp>
+        <p:nvSpPr>
+          <p:cNvPr id="2" name="TextBox 1"/>
+          <p:cNvSpPr txBox="1"/>
+          <p:nvPr/>
+        </p:nvSpPr>
+        <p:spPr>
+          <a:xfrm>
+            <a:off x="731520" y="457200"/>
+            <a:ext cx="10058400" cy="365760"/>
+          </a:xfrm>
+          <a:prstGeom prst="rect">
+            <a:avLst/>
+          </a:prstGeom>
+          <a:noFill/>
+        </p:spPr>
+        <p:txBody>
+          <a:bodyPr wrap="square">
+            <a:spAutoFit/>
+          </a:bodyPr>
+          <a:lstStyle/>
+          <a:p>
+            <a:pPr>
+              <a:defRPr sz="1000" b="1">
+                <a:solidFill>
+                  <a:srgbClr val="7C3AED"/>
+                </a:solidFill>
+              </a:defRPr>
+            </a:pPr>
+            <a:r>
+              <a:t>MULTIMODAL AI RAG AGENT ARCHITECTURE</a:t>
+            </a:r>
+          </a:p>
+        </p:txBody>
+      </p:sp>
+      <p:sp>
+        <p:nvSpPr>
+          <p:cNvPr id="3" name="TextBox 2"/>
+          <p:cNvSpPr txBox="1"/>
+          <p:nvPr/>
+        </p:nvSpPr>
+        <p:spPr>
+          <a:xfrm>
+            <a:off x="731520" y="731520"/>
+            <a:ext cx="10058400" cy="731520"/>
+          </a:xfrm>
+          <a:prstGeom prst="rect">
+            <a:avLst/>
+          </a:prstGeom>
+          <a:noFill/>
+        </p:spPr>
+        <p:txBody>
+          <a:bodyPr wrap="square">
+            <a:spAutoFit/>
+          </a:bodyPr>
+          <a:lstStyle/>
+          <a:p>
+            <a:pPr>
+              <a:defRPr sz="2400" b="1">
+                <a:solidFill>
+                  <a:srgbClr val="212529"/>
+                </a:solidFill>
+              </a:defRPr>
+            </a:pPr>
+            <a:r>
+              <a:t>Cross-Modal Retrieval Mechanics</a:t>
+            </a:r>
+          </a:p>
+        </p:txBody>
+      </p:sp>
+      <p:sp>
+        <p:nvSpPr>
+          <p:cNvPr id="4" name="Rounded Rectangle 3"/>
+          <p:cNvSpPr/>
+          <p:nvPr/>
+        </p:nvSpPr>
+        <p:spPr>
+          <a:xfrm>
+            <a:off x="731520" y="1645920"/>
+            <a:ext cx="10728655" cy="1005840"/>
+          </a:xfrm>
+          <a:prstGeom prst="roundRect">
+            <a:avLst/>
+          </a:prstGeom>
+          <a:solidFill>
+            <a:srgbClr val="FFFFFF"/>
+          </a:solidFill>
+          <a:ln>
+            <a:solidFill>
+              <a:srgbClr val="E2E8F0"/>
+            </a:solidFill>
+          </a:ln>
+        </p:spPr>
+        <p:style>
+          <a:lnRef idx="1">
+            <a:schemeClr val="accent1"/>
+          </a:lnRef>
+          <a:fillRef idx="3">
+            <a:schemeClr val="accent1"/>
+          </a:fillRef>
+          <a:effectRef idx="2">
+            <a:schemeClr val="accent1"/>
+          </a:effectRef>
+          <a:fontRef idx="minor">
+            <a:schemeClr val="lt1"/>
+          </a:fontRef>
+        </p:style>
+        <p:txBody>
+          <a:bodyPr rtlCol="0" anchor="ctr" wrap="square" lIns="274320" tIns="182880"/>
+          <a:lstStyle/>
+          <a:p>
+            <a:pPr algn="ctr">
+              <a:spcAft>
+                <a:spcPts val="400"/>
+              </a:spcAft>
+              <a:defRPr sz="1600" b="1">
+                <a:solidFill>
+                  <a:srgbClr val="7C3AED"/>
+                </a:solidFill>
+              </a:defRPr>
+            </a:pPr>
+            <a:r>
+              <a:t>1. Query Analysis</a:t>
+            </a:r>
+          </a:p>
+          <a:p>
+            <a:pPr>
+              <a:defRPr sz="1300">
+                <a:solidFill>
+                  <a:srgbClr val="212529"/>
+                </a:solidFill>
+              </a:defRPr>
+            </a:pPr>
+            <a:r>
+              <a:t>Analyzes user query to generate embeddings compatible with multi-vector indices.</a:t>
+            </a:r>
+          </a:p>
+        </p:txBody>
+      </p:sp>
+      <p:sp>
+        <p:nvSpPr>
+          <p:cNvPr id="5" name="Rounded Rectangle 4"/>
+          <p:cNvSpPr/>
+          <p:nvPr/>
+        </p:nvSpPr>
+        <p:spPr>
+          <a:xfrm>
+            <a:off x="731520" y="2788920"/>
+            <a:ext cx="10728655" cy="1005840"/>
+          </a:xfrm>
+          <a:prstGeom prst="roundRect">
+            <a:avLst/>
+          </a:prstGeom>
+          <a:solidFill>
+            <a:srgbClr val="FFFFFF"/>
+          </a:solidFill>
+          <a:ln>
+            <a:solidFill>
+              <a:srgbClr val="E2E8F0"/>
+            </a:solidFill>
+          </a:ln>
+        </p:spPr>
+        <p:style>
+          <a:lnRef idx="1">
+            <a:schemeClr val="accent1"/>
+          </a:lnRef>
+          <a:fillRef idx="3">
+            <a:schemeClr val="accent1"/>
+          </a:fillRef>
+          <a:effectRef idx="2">
+            <a:schemeClr val="accent1"/>
+          </a:effectRef>
+          <a:fontRef idx="minor">
+            <a:schemeClr val="lt1"/>
+          </a:fontRef>
+        </p:style>
+        <p:txBody>
+          <a:bodyPr rtlCol="0" anchor="ctr" wrap="square" lIns="274320" tIns="182880"/>
+          <a:lstStyle/>
+          <a:p>
+            <a:pPr algn="ctr">
+              <a:spcAft>
+                <a:spcPts val="400"/>
+              </a:spcAft>
+              <a:defRPr sz="1600" b="1">
+                <a:solidFill>
+                  <a:srgbClr val="7C3AED"/>
+                </a:solidFill>
+              </a:defRPr>
+            </a:pPr>
+            <a:r>
+              <a:t>2. Cross-Modal Matching</a:t>
+            </a:r>
+          </a:p>
+          <a:p>
+            <a:pPr>
+              <a:defRPr sz="1300">
+                <a:solidFill>
+                  <a:srgbClr val="212529"/>
+                </a:solidFill>
+              </a:defRPr>
+            </a:pPr>
+            <a:r>
+              <a:t>Searches across text blocks, diagram descriptions, and image embedding tables.</a:t>
+            </a:r>
+          </a:p>
+        </p:txBody>
+      </p:sp>
+      <p:sp>
+        <p:nvSpPr>
+          <p:cNvPr id="6" name="Rounded Rectangle 5"/>
+          <p:cNvSpPr/>
+          <p:nvPr/>
+        </p:nvSpPr>
+        <p:spPr>
+          <a:xfrm>
+            <a:off x="731520" y="3931920"/>
+            <a:ext cx="10728655" cy="1005840"/>
+          </a:xfrm>
+          <a:prstGeom prst="roundRect">
+            <a:avLst/>
+          </a:prstGeom>
+          <a:solidFill>
+            <a:srgbClr val="FFFFFF"/>
+          </a:solidFill>
+          <a:ln>
+            <a:solidFill>
+              <a:srgbClr val="E2E8F0"/>
+            </a:solidFill>
+          </a:ln>
+        </p:spPr>
+        <p:style>
+          <a:lnRef idx="1">
+            <a:schemeClr val="accent1"/>
+          </a:lnRef>
+          <a:fillRef idx="3">
+            <a:schemeClr val="accent1"/>
+          </a:fillRef>
+          <a:effectRef idx="2">
+            <a:schemeClr val="accent1"/>
+          </a:effectRef>
+          <a:fontRef idx="minor">
+            <a:schemeClr val="lt1"/>
+          </a:fontRef>
+        </p:style>
+        <p:txBody>
+          <a:bodyPr rtlCol="0" anchor="ctr" wrap="square" lIns="274320" tIns="182880"/>
+          <a:lstStyle/>
+          <a:p>
+            <a:pPr algn="ctr">
+              <a:spcAft>
+                <a:spcPts val="400"/>
+              </a:spcAft>
+              <a:defRPr sz="1600" b="1">
+                <a:solidFill>
+                  <a:srgbClr val="7C3AED"/>
+                </a:solidFill>
+              </a:defRPr>
+            </a:pPr>
+            <a:r>
+              <a:t>3. Visual Context Ingestion</a:t>
+            </a:r>
+          </a:p>
+          <a:p>
+            <a:pPr>
+              <a:defRPr sz="1300">
+                <a:solidFill>
+                  <a:srgbClr val="212529"/>
+                </a:solidFill>
+              </a:defRPr>
+            </a:pPr>
+            <a:r>
+              <a:t>Packs image payloads and text metadata directly into the system message.</a:t>
+            </a:r>
+          </a:p>
+        </p:txBody>
+      </p:sp>
+      <p:sp>
+        <p:nvSpPr>
+          <p:cNvPr id="7" name="Rounded Rectangle 6"/>
+          <p:cNvSpPr/>
+          <p:nvPr/>
+        </p:nvSpPr>
+        <p:spPr>
+          <a:xfrm>
+            <a:off x="731520" y="5074920"/>
+            <a:ext cx="10728655" cy="1005840"/>
+          </a:xfrm>
+          <a:prstGeom prst="roundRect">
+            <a:avLst/>
+          </a:prstGeom>
+          <a:solidFill>
+            <a:srgbClr val="FFFFFF"/>
+          </a:solidFill>
+          <a:ln>
+            <a:solidFill>
+              <a:srgbClr val="E2E8F0"/>
+            </a:solidFill>
+          </a:ln>
+        </p:spPr>
+        <p:style>
+          <a:lnRef idx="1">
+            <a:schemeClr val="accent1"/>
+          </a:lnRef>
+          <a:fillRef idx="3">
+            <a:schemeClr val="accent1"/>
+          </a:fillRef>
+          <a:effectRef idx="2">
+            <a:schemeClr val="accent1"/>
+          </a:effectRef>
+          <a:fontRef idx="minor">
+            <a:schemeClr val="lt1"/>
+          </a:fontRef>
+        </p:style>
+        <p:txBody>
+          <a:bodyPr rtlCol="0" anchor="ctr" wrap="square" lIns="274320" tIns="182880"/>
+          <a:lstStyle/>
+          <a:p>
+            <a:pPr algn="ctr">
+              <a:spcAft>
+                <a:spcPts val="400"/>
+              </a:spcAft>
+              <a:defRPr sz="1600" b="1">
+                <a:solidFill>
+                  <a:srgbClr val="7C3AED"/>
+                </a:solidFill>
+              </a:defRPr>
+            </a:pPr>
+            <a:r>
+              <a:t>4. Source Attribution</a:t>
+            </a:r>
+          </a:p>
+          <a:p>
+            <a:pPr>
+              <a:defRPr sz="1300">
+                <a:solidFill>
+                  <a:srgbClr val="212529"/>
+                </a:solidFill>
+              </a:defRPr>
+            </a:pPr>
+            <a:r>
+              <a:t>Grounds answers strictly in retrieved chunks to prevent hallucinated statements.</a:t>
+            </a:r>
+          </a:p>
+        </p:txBody>
+      </p:sp>
+    </p:spTree>
+  </p:cSld>
+  <p:clrMapOvr>
+    <a:masterClrMapping/>
+  </p:clrMapOvr>
+</p:sld>
+</file>
+
+<file path=ppt/slides/slide8.xml><?xml version="1.0" encoding="utf-8"?>
+<p:sld xmlns:a="http://schemas.openxmlformats.org/drawingml/2006/main" xmlns:p="http://schemas.openxmlformats.org/presentationml/2006/main" xmlns:r="http://schemas.openxmlformats.org/officeDocument/2006/relationships">
+  <p:cSld>
+    <p:bg>
+      <p:bgPr>
+        <a:solidFill>
+          <a:srgbClr val="F8F9FA"/>
+        </a:solidFill>
+        <a:effectLst/>
+      </p:bgPr>
+    </p:bg>
+    <p:spTree>
+      <p:nvGrpSpPr>
+        <p:cNvPr id="1" name=""/>
+        <p:cNvGrpSpPr/>
+        <p:nvPr/>
+      </p:nvGrpSpPr>
+      <p:grpSpPr/>
+      <p:sp>
+        <p:nvSpPr>
+          <p:cNvPr id="2" name="TextBox 1"/>
+          <p:cNvSpPr txBox="1"/>
+          <p:nvPr/>
+        </p:nvSpPr>
+        <p:spPr>
+          <a:xfrm>
+            <a:off x="731520" y="457200"/>
+            <a:ext cx="10058400" cy="365760"/>
+          </a:xfrm>
+          <a:prstGeom prst="rect">
+            <a:avLst/>
+          </a:prstGeom>
+          <a:noFill/>
+        </p:spPr>
+        <p:txBody>
+          <a:bodyPr wrap="square">
+            <a:spAutoFit/>
+          </a:bodyPr>
+          <a:lstStyle/>
+          <a:p>
+            <a:pPr>
+              <a:defRPr sz="1000" b="1">
+                <a:solidFill>
+                  <a:srgbClr val="7C3AED"/>
+                </a:solidFill>
+              </a:defRPr>
+            </a:pPr>
+            <a:r>
+              <a:t>MULTIMODAL AI RAG AGENT ARCHITECTURE</a:t>
+            </a:r>
+          </a:p>
+        </p:txBody>
+      </p:sp>
+      <p:sp>
+        <p:nvSpPr>
+          <p:cNvPr id="3" name="TextBox 2"/>
+          <p:cNvSpPr txBox="1"/>
+          <p:nvPr/>
+        </p:nvSpPr>
+        <p:spPr>
+          <a:xfrm>
+            <a:off x="731520" y="731520"/>
+            <a:ext cx="10058400" cy="731520"/>
+          </a:xfrm>
+          <a:prstGeom prst="rect">
+            <a:avLst/>
+          </a:prstGeom>
+          <a:noFill/>
+        </p:spPr>
+        <p:txBody>
+          <a:bodyPr wrap="square">
+            <a:spAutoFit/>
+          </a:bodyPr>
+          <a:lstStyle/>
+          <a:p>
+            <a:pPr>
+              <a:defRPr sz="2400" b="1">
+                <a:solidFill>
+                  <a:srgbClr val="212529"/>
+                </a:solidFill>
+              </a:defRPr>
+            </a:pPr>
+            <a:r>
+              <a:t>Multimodal Capabilities &amp; Advantages</a:t>
+            </a:r>
+          </a:p>
+        </p:txBody>
+      </p:sp>
+      <p:graphicFrame>
+        <p:nvGraphicFramePr>
+          <p:cNvPr id="4" name="Table 3"/>
+          <p:cNvGraphicFramePr>
+            <a:graphicFrameLocks noGrp="1"/>
+          </p:cNvGraphicFramePr>
+          <p:nvPr/>
+        </p:nvGraphicFramePr>
+        <p:xfrm>
+          <a:off x="731520" y="1645920"/>
+          <a:ext cx="10728655" cy="4114800"/>
+        </p:xfrm>
+        <a:graphic>
+          <a:graphicData uri="http://schemas.openxmlformats.org/drawingml/2006/table">
+            <a:tbl>
+              <a:tblPr firstRow="1" bandRow="1">
+                <a:tableStyleId>{5C22544A-7EE6-4342-B048-85BDC9FD1C3A}</a:tableStyleId>
+              </a:tblPr>
+              <a:tblGrid>
+                <a:gridCol w="3200400"/>
+                <a:gridCol w="7528255"/>
+              </a:tblGrid>
+              <a:tr h="822960">
+                <a:tc>
+                  <a:txBody>
+                    <a:bodyPr/>
+                    <a:lstStyle/>
+                    <a:p>
+                      <a:pPr>
+                        <a:defRPr b="1" sz="1400">
+                          <a:solidFill>
+                            <a:srgbClr val="FFFFFF"/>
+                          </a:solidFill>
+                        </a:defRPr>
+                      </a:pPr>
+                      <a:r>
+                        <a:t>System Dimension</a:t>
+                      </a:r>
+                    </a:p>
+                  </a:txBody>
+                  <a:tcPr>
+                    <a:solidFill>
+                      <a:srgbClr val="7C3AED"/>
+                    </a:solidFill>
+                  </a:tcPr>
+                </a:tc>
+                <a:tc>
+                  <a:txBody>
+                    <a:bodyPr/>
+                    <a:lstStyle/>
+                    <a:p>
+                      <a:pPr>
+                        <a:defRPr b="1" sz="1400">
+                          <a:solidFill>
+                            <a:srgbClr val="FFFFFF"/>
+                          </a:solidFill>
+                        </a:defRPr>
+                      </a:pPr>
+                      <a:r>
+                        <a:t>Multimodal RAG Advantage</a:t>
+                      </a:r>
+                    </a:p>
+                  </a:txBody>
+                  <a:tcPr>
+                    <a:solidFill>
+                      <a:srgbClr val="7C3AED"/>
+                    </a:solidFill>
+                  </a:tcPr>
+                </a:tc>
+              </a:tr>
+              <a:tr h="822960">
+                <a:tc>
+                  <a:txBody>
+                    <a:bodyPr/>
+                    <a:lstStyle/>
+                    <a:p>
+                      <a:pPr>
+                        <a:defRPr sz="1200" b="1">
+                          <a:solidFill>
+                            <a:srgbClr val="212529"/>
+                          </a:solidFill>
+                        </a:defRPr>
+                      </a:pPr>
+                      <a:r>
+                        <a:t>Information Processing</a:t>
+                      </a:r>
+                    </a:p>
+                  </a:txBody>
+                  <a:tcPr>
+                    <a:solidFill>
+                      <a:srgbClr val="FFFFFF"/>
+                    </a:solidFill>
+                  </a:tcPr>
+                </a:tc>
+                <a:tc>
+                  <a:txBody>
+                    <a:bodyPr/>
+                    <a:lstStyle/>
+                    <a:p>
+                      <a:pPr>
+                        <a:defRPr sz="1200">
+                          <a:solidFill>
+                            <a:srgbClr val="6C757D"/>
+                          </a:solidFill>
+                        </a:defRPr>
+                      </a:pPr>
+                      <a:r>
+                        <a:t>Processes text documents, code files, and architectural diagrams simultaneously.</a:t>
+                      </a:r>
+                    </a:p>
+                  </a:txBody>
+                  <a:tcPr>
+                    <a:solidFill>
+                      <a:srgbClr val="FFFFFF"/>
+                    </a:solidFill>
+                  </a:tcPr>
+                </a:tc>
+              </a:tr>
+              <a:tr h="822960">
+                <a:tc>
+                  <a:txBody>
+                    <a:bodyPr/>
+                    <a:lstStyle/>
+                    <a:p>
+                      <a:pPr>
+                        <a:defRPr sz="1200" b="1">
+                          <a:solidFill>
+                            <a:srgbClr val="212529"/>
+                          </a:solidFill>
+                        </a:defRPr>
+                      </a:pPr>
+                      <a:r>
+                        <a:t>Answer Accuracy</a:t>
+                      </a:r>
+                    </a:p>
+                  </a:txBody>
+                  <a:tcPr>
+                    <a:solidFill>
+                      <a:srgbClr val="F1F5F9"/>
+                    </a:solidFill>
+                  </a:tcPr>
+                </a:tc>
+                <a:tc>
+                  <a:txBody>
+                    <a:bodyPr/>
+                    <a:lstStyle/>
+                    <a:p>
+                      <a:pPr>
+                        <a:defRPr sz="1200">
+                          <a:solidFill>
+                            <a:srgbClr val="6C757D"/>
+                          </a:solidFill>
+                        </a:defRPr>
+                      </a:pPr>
+                      <a:r>
+                        <a:t>Grounds answers in both visual proof and textual context to eliminate speculation.</a:t>
+                      </a:r>
+                    </a:p>
+                  </a:txBody>
+                  <a:tcPr>
+                    <a:solidFill>
+                      <a:srgbClr val="F1F5F9"/>
+                    </a:solidFill>
+                  </a:tcPr>
+                </a:tc>
+              </a:tr>
+              <a:tr h="822960">
+                <a:tc>
+                  <a:txBody>
+                    <a:bodyPr/>
+                    <a:lstStyle/>
+                    <a:p>
+                      <a:pPr>
+                        <a:defRPr sz="1200" b="1">
+                          <a:solidFill>
+                            <a:srgbClr val="212529"/>
+                          </a:solidFill>
+                        </a:defRPr>
+                      </a:pPr>
+                      <a:r>
+                        <a:t>API Integration</a:t>
+                      </a:r>
+                    </a:p>
+                  </a:txBody>
+                  <a:tcPr>
+                    <a:solidFill>
+                      <a:srgbClr val="FFFFFF"/>
+                    </a:solidFill>
+                  </a:tcPr>
+                </a:tc>
+                <a:tc>
+                  <a:txBody>
+                    <a:bodyPr/>
+                    <a:lstStyle/>
+                    <a:p>
+                      <a:pPr>
+                        <a:defRPr sz="1200">
+                          <a:solidFill>
+                            <a:srgbClr val="6C757D"/>
+                          </a:solidFill>
+                        </a:defRPr>
+                      </a:pPr>
+                      <a:r>
+                        <a:t>Outputs validated AgentResponse objects ready for automated application backends.</a:t>
+                      </a:r>
+                    </a:p>
+                  </a:txBody>
+                  <a:tcPr>
+                    <a:solidFill>
+                      <a:srgbClr val="FFFFFF"/>
+                    </a:solidFill>
+                  </a:tcPr>
+                </a:tc>
+              </a:tr>
+              <a:tr h="822960">
+                <a:tc>
+                  <a:txBody>
+                    <a:bodyPr/>
+                    <a:lstStyle/>
+                    <a:p>
+                      <a:pPr>
+                        <a:defRPr sz="1200" b="1">
+                          <a:solidFill>
+                            <a:srgbClr val="212529"/>
+                          </a:solidFill>
+                        </a:defRPr>
+                      </a:pPr>
+                      <a:r>
+                        <a:t>Modular Extensibility</a:t>
+                      </a:r>
+                    </a:p>
+                  </a:txBody>
+                  <a:tcPr>
+                    <a:solidFill>
+                      <a:srgbClr val="F1F5F9"/>
+                    </a:solidFill>
+                  </a:tcPr>
+                </a:tc>
+                <a:tc>
+                  <a:txBody>
+                    <a:bodyPr/>
+                    <a:lstStyle/>
+                    <a:p>
+                      <a:pPr>
+                        <a:defRPr sz="1200">
+                          <a:solidFill>
+                            <a:srgbClr val="6C757D"/>
+                          </a:solidFill>
+                        </a:defRPr>
+                      </a:pPr>
+                      <a:r>
+                        <a:t>Decouples indexers, schemas, prompts, and loggers for easy future expansion.</a:t>
+                      </a:r>
+                    </a:p>
+                  </a:txBody>
+                  <a:tcPr>
+                    <a:solidFill>
+                      <a:srgbClr val="F1F5F9"/>
+                    </a:solidFill>
+                  </a:tcPr>
+                </a:tc>
+              </a:tr>
+            </a:tbl>
+          </a:graphicData>
+        </a:graphic>
+      </p:graphicFrame>
+    </p:spTree>
+  </p:cSld>
+  <p:clrMapOvr>
+    <a:masterClrMapping/>
+  </p:clrMapOvr>
+</p:sld>
+</file>
+
+<file path=ppt/slides/slide9.xml><?xml version="1.0" encoding="utf-8"?>
+<p:sld xmlns:a="http://schemas.openxmlformats.org/drawingml/2006/main" xmlns:p="http://schemas.openxmlformats.org/presentationml/2006/main" xmlns:r="http://schemas.openxmlformats.org/officeDocument/2006/relationships">
+  <p:cSld>
+    <p:bg>
+      <p:bgPr>
+        <a:solidFill>
+          <a:srgbClr val="F8F9FA"/>
+        </a:solidFill>
+        <a:effectLst/>
+      </p:bgPr>
+    </p:bg>
+    <p:spTree>
+      <p:nvGrpSpPr>
+        <p:cNvPr id="1" name=""/>
+        <p:cNvGrpSpPr/>
+        <p:nvPr/>
+      </p:nvGrpSpPr>
+      <p:grpSpPr/>
+      <p:sp>
+        <p:nvSpPr>
+          <p:cNvPr id="2" name="TextBox 1"/>
+          <p:cNvSpPr txBox="1"/>
+          <p:nvPr/>
+        </p:nvSpPr>
+        <p:spPr>
+          <a:xfrm>
+            <a:off x="731520" y="457200"/>
+            <a:ext cx="10058400" cy="365760"/>
+          </a:xfrm>
+          <a:prstGeom prst="rect">
+            <a:avLst/>
+          </a:prstGeom>
+          <a:noFill/>
+        </p:spPr>
+        <p:txBody>
+          <a:bodyPr wrap="square">
+            <a:spAutoFit/>
+          </a:bodyPr>
+          <a:lstStyle/>
+          <a:p>
+            <a:pPr>
+              <a:defRPr sz="1000" b="1">
+                <a:solidFill>
+                  <a:srgbClr val="7C3AED"/>
+                </a:solidFill>
+              </a:defRPr>
+            </a:pPr>
+            <a:r>
+              <a:t>MULTIMODAL AI RAG AGENT ARCHITECTURE</a:t>
+            </a:r>
+          </a:p>
+        </p:txBody>
+      </p:sp>
+      <p:sp>
+        <p:nvSpPr>
+          <p:cNvPr id="3" name="TextBox 2"/>
+          <p:cNvSpPr txBox="1"/>
+          <p:nvPr/>
+        </p:nvSpPr>
+        <p:spPr>
+          <a:xfrm>
+            <a:off x="731520" y="731520"/>
+            <a:ext cx="10058400" cy="731520"/>
+          </a:xfrm>
+          <a:prstGeom prst="rect">
+            <a:avLst/>
+          </a:prstGeom>
+          <a:noFill/>
+        </p:spPr>
+        <p:txBody>
+          <a:bodyPr wrap="square">
+            <a:spAutoFit/>
+          </a:bodyPr>
+          <a:lstStyle/>
+          <a:p>
+            <a:pPr>
+              <a:defRPr sz="2400" b="1">
+                <a:solidFill>
+                  <a:srgbClr val="212529"/>
+                </a:solidFill>
+              </a:defRPr>
+            </a:pPr>
+            <a:r>
+              <a:t>Project Summary &amp; Key Takeaways</a:t>
             </a:r>
           </a:p>
         </p:txBody>
@@ -4358,20 +5801,20 @@
               <a:spcAft>
                 <a:spcPts val="200"/>
               </a:spcAft>
-              <a:defRPr sz="1600" b="1">
+              <a:defRPr sz="1500" b="1">
                 <a:solidFill>
                   <a:srgbClr val="7C3AED"/>
                 </a:solidFill>
               </a:defRPr>
             </a:pPr>
             <a:r>
-              <a:t>• Strict Modular Architecture</a:t>
+              <a:t>• Unified Multimodal Intelligence</a:t>
             </a:r>
           </a:p>
           <a:p>
             <a:pPr>
               <a:spcAft>
-                <a:spcPts val="1400"/>
+                <a:spcPts val="1200"/>
               </a:spcAft>
               <a:defRPr sz="1300">
                 <a:solidFill>
@@ -4380,7 +5823,7 @@
               </a:defRPr>
             </a:pPr>
             <a:r>
-              <a:t>Separates concerns across retrieval pipelines, schema definitions, prompt configurations, and utility loggers.</a:t>
+              <a:t>Extends traditional RAG to process mixed media (text, images, and visual diagrams) seamlessly.</a:t>
             </a:r>
           </a:p>
           <a:p>
@@ -4388,20 +5831,20 @@
               <a:spcAft>
                 <a:spcPts val="200"/>
               </a:spcAft>
-              <a:defRPr sz="1600" b="1">
+              <a:defRPr sz="1500" b="1">
                 <a:solidFill>
                   <a:srgbClr val="7C3AED"/>
                 </a:solidFill>
               </a:defRPr>
             </a:pPr>
             <a:r>
-              <a:t>• Guaranteed Response Schema</a:t>
+              <a:t>• Strict Schema Enforcement</a:t>
             </a:r>
           </a:p>
           <a:p>
             <a:pPr>
               <a:spcAft>
-                <a:spcPts val="1400"/>
+                <a:spcPts val="1200"/>
               </a:spcAft>
               <a:defRPr sz="1300">
                 <a:solidFill>
@@ -4410,7 +5853,7 @@
               </a:defRPr>
             </a:pPr>
             <a:r>
-              <a:t>Employs Pydantic structured output binding to eliminate raw parsing errors.</a:t>
+              <a:t>Uses Pydantic structured output binding to deliver deterministic, system-ready outputs.</a:t>
             </a:r>
           </a:p>
           <a:p>
@@ -4418,20 +5861,20 @@
               <a:spcAft>
                 <a:spcPts val="200"/>
               </a:spcAft>
-              <a:defRPr sz="1600" b="1">
+              <a:defRPr sz="1500" b="1">
                 <a:solidFill>
                   <a:srgbClr val="7C3AED"/>
                 </a:solidFill>
               </a:defRPr>
             </a:pPr>
             <a:r>
-              <a:t>• Deterministic RAG Execution</a:t>
+              <a:t>• Production-Ready Design</a:t>
             </a:r>
           </a:p>
           <a:p>
             <a:pPr>
               <a:spcAft>
-                <a:spcPts val="1400"/>
+                <a:spcPts val="1200"/>
               </a:spcAft>
               <a:defRPr sz="1300">
                 <a:solidFill>
@@ -4440,7 +5883,37 @@
               </a:defRPr>
             </a:pPr>
             <a:r>
-              <a:t>Zero-temperature LLM settings ensure deterministic answers grounded strictly in retrieved context chunks.</a:t>
+              <a:t>Organized across modular subpackages (src.chains, src.retrieval, src.utils) for high maintainability.</a:t>
+            </a:r>
+          </a:p>
+          <a:p>
+            <a:pPr>
+              <a:spcAft>
+                <a:spcPts val="200"/>
+              </a:spcAft>
+              <a:defRPr sz="1500" b="1">
+                <a:solidFill>
+                  <a:srgbClr val="7C3AED"/>
+                </a:solidFill>
+              </a:defRPr>
+            </a:pPr>
+            <a:r>
+              <a:t>• Grounded &amp; Verifiable</a:t>
+            </a:r>
+          </a:p>
+          <a:p>
+            <a:pPr>
+              <a:spcAft>
+                <a:spcPts val="1200"/>
+              </a:spcAft>
+              <a:defRPr sz="1300">
+                <a:solidFill>
+                  <a:srgbClr val="6C757D"/>
+                </a:solidFill>
+              </a:defRPr>
+            </a:pPr>
+            <a:r>
+              <a:t>Prevents model hallucination by enforcing strict context retrieval prior to generation.</a:t>
             </a:r>
           </a:p>
         </p:txBody>

</xml_diff>